<commit_message>
docs(presentation): rebuild deck with agent-rings diagram
- Replace static slide JPG exports + Node build script with Python-built agent-rings SVG/PNG/HTML and updated arch diagram.
- Refresh MMC_Demo_Overview.pptx; drop stale exported PDF.

Co-authored-by: Copilot <223556219+Copilot@users.noreply.github.com>
</commit_message>
<xml_diff>
--- a/docs/presentation/MMC_Demo_Overview.pptx
+++ b/docs/presentation/MMC_Demo_Overview.pptx
@@ -4167,8 +4167,8 @@
         </p:blipFill>
         <p:spPr>
           <a:xfrm>
-            <a:off x="746608" y="1481328"/>
-            <a:ext cx="10698480" cy="6718307"/>
+            <a:off x="2155275" y="1554480"/>
+            <a:ext cx="7881145" cy="4892040"/>
           </a:xfrm>
           <a:prstGeom prst="rect">
             <a:avLst/>
@@ -4183,8 +4183,8 @@
         </p:nvSpPr>
         <p:spPr>
           <a:xfrm>
-            <a:off x="746608" y="1481328"/>
-            <a:ext cx="10698480" cy="6718307"/>
+            <a:off x="2155275" y="1554480"/>
+            <a:ext cx="7881145" cy="4892040"/>
           </a:xfrm>
           <a:prstGeom prst="rect">
             <a:avLst/>

</xml_diff>